<commit_message>
feat: feature-importance explainability + live-demo QR code
- ml.py: new get_feature_importances() aggregates one-hot weights
  back to the 7 original inputs (Employee country tops at 52%)
- dashboard.py: "Feature Influence" section renders a colour-coded
  horizontal bar chart with each user input annotated on hover
- make_ppt.py: title slide now shows a QR card pointing to the
  Streamlit Cloud URL so the audience can try the app during the pitch
- artifacts/streamlit_qr.png: branded teal/dark QR asset

Co-Authored-By: Claude Opus 4.6 <noreply@anthropic.com>
</commit_message>
<xml_diff>
--- a/PayScope_Presentation.pptx
+++ b/PayScope_Presentation.pptx
@@ -7570,7 +7570,227 @@
       </p:sp>
       <p:sp>
         <p:nvSpPr>
-          <p:cNvPr id="97" name="Rectangle 96"/>
+          <p:cNvPr id="97" name="Rounded Rectangle 96"/>
+          <p:cNvSpPr/>
+          <p:nvPr/>
+        </p:nvSpPr>
+        <p:spPr>
+          <a:xfrm>
+            <a:off x="9692640" y="457200"/>
+            <a:ext cx="2103120" cy="2651760"/>
+          </a:xfrm>
+          <a:prstGeom prst="roundRect">
+            <a:avLst>
+              <a:gd name="adj" fmla="val 8000"/>
+            </a:avLst>
+          </a:prstGeom>
+          <a:solidFill>
+            <a:srgbClr val="12172B"/>
+          </a:solidFill>
+          <a:ln>
+            <a:noFill/>
+          </a:ln>
+        </p:spPr>
+        <p:style>
+          <a:lnRef idx="1">
+            <a:schemeClr val="accent1"/>
+          </a:lnRef>
+          <a:fillRef idx="3">
+            <a:schemeClr val="accent1"/>
+          </a:fillRef>
+          <a:effectRef idx="2">
+            <a:schemeClr val="accent1"/>
+          </a:effectRef>
+          <a:fontRef idx="minor">
+            <a:schemeClr val="lt1"/>
+          </a:fontRef>
+        </p:style>
+        <p:txBody>
+          <a:bodyPr rtlCol="0" anchor="ctr"/>
+          <a:lstStyle/>
+          <a:p>
+            <a:pPr algn="ctr"/>
+          </a:p>
+        </p:txBody>
+      </p:sp>
+      <p:sp>
+        <p:nvSpPr>
+          <p:cNvPr id="98" name="Rectangle 97"/>
+          <p:cNvSpPr/>
+          <p:nvPr/>
+        </p:nvSpPr>
+        <p:spPr>
+          <a:xfrm>
+            <a:off x="9692640" y="457200"/>
+            <a:ext cx="2103120" cy="109728"/>
+          </a:xfrm>
+          <a:prstGeom prst="rect">
+            <a:avLst/>
+          </a:prstGeom>
+          <a:solidFill>
+            <a:srgbClr val="00E5C3"/>
+          </a:solidFill>
+          <a:ln>
+            <a:noFill/>
+          </a:ln>
+        </p:spPr>
+        <p:style>
+          <a:lnRef idx="1">
+            <a:schemeClr val="accent1"/>
+          </a:lnRef>
+          <a:fillRef idx="3">
+            <a:schemeClr val="accent1"/>
+          </a:fillRef>
+          <a:effectRef idx="2">
+            <a:schemeClr val="accent1"/>
+          </a:effectRef>
+          <a:fontRef idx="minor">
+            <a:schemeClr val="lt1"/>
+          </a:fontRef>
+        </p:style>
+        <p:txBody>
+          <a:bodyPr rtlCol="0" anchor="ctr"/>
+          <a:lstStyle/>
+          <a:p>
+            <a:pPr algn="ctr"/>
+          </a:p>
+        </p:txBody>
+      </p:sp>
+      <p:sp>
+        <p:nvSpPr>
+          <p:cNvPr id="99" name="TextBox 98"/>
+          <p:cNvSpPr txBox="1"/>
+          <p:nvPr/>
+        </p:nvSpPr>
+        <p:spPr>
+          <a:xfrm>
+            <a:off x="9784080" y="640080"/>
+            <a:ext cx="1920240" cy="274320"/>
+          </a:xfrm>
+          <a:prstGeom prst="rect">
+            <a:avLst/>
+          </a:prstGeom>
+          <a:noFill/>
+        </p:spPr>
+        <p:txBody>
+          <a:bodyPr wrap="square" lIns="0" rIns="0" tIns="0" bIns="0">
+            <a:spAutoFit/>
+          </a:bodyPr>
+          <a:lstStyle/>
+          <a:p>
+            <a:pPr algn="ctr">
+              <a:defRPr sz="1000" b="1">
+                <a:solidFill>
+                  <a:srgbClr val="00E5C3"/>
+                </a:solidFill>
+                <a:latin typeface="Segoe UI"/>
+              </a:defRPr>
+            </a:pPr>
+            <a:r>
+              <a:t>SCAN  •  TRY IT LIVE</a:t>
+            </a:r>
+          </a:p>
+        </p:txBody>
+      </p:sp>
+      <p:pic>
+        <p:nvPicPr>
+          <p:cNvPr id="100" name="Picture 99" descr="streamlit_qr.png"/>
+          <p:cNvPicPr>
+            <a:picLocks noChangeAspect="1"/>
+          </p:cNvPicPr>
+          <p:nvPr/>
+        </p:nvPicPr>
+        <p:blipFill>
+          <a:blip r:embed="rId2"/>
+          <a:stretch>
+            <a:fillRect/>
+          </a:stretch>
+        </p:blipFill>
+        <p:spPr>
+          <a:xfrm>
+            <a:off x="9921240" y="960120"/>
+            <a:ext cx="1645920" cy="1645920"/>
+          </a:xfrm>
+          <a:prstGeom prst="rect">
+            <a:avLst/>
+          </a:prstGeom>
+        </p:spPr>
+      </p:pic>
+      <p:sp>
+        <p:nvSpPr>
+          <p:cNvPr id="101" name="TextBox 100"/>
+          <p:cNvSpPr txBox="1"/>
+          <p:nvPr/>
+        </p:nvSpPr>
+        <p:spPr>
+          <a:xfrm>
+            <a:off x="9784080" y="2697480"/>
+            <a:ext cx="1920240" cy="274320"/>
+          </a:xfrm>
+          <a:prstGeom prst="rect">
+            <a:avLst/>
+          </a:prstGeom>
+          <a:noFill/>
+        </p:spPr>
+        <p:txBody>
+          <a:bodyPr wrap="square" lIns="0" rIns="0" tIns="0" bIns="0">
+            <a:spAutoFit/>
+          </a:bodyPr>
+          <a:lstStyle/>
+          <a:p>
+            <a:pPr algn="ctr">
+              <a:defRPr sz="800" b="0">
+                <a:solidFill>
+                  <a:srgbClr val="8B95A8"/>
+                </a:solidFill>
+                <a:latin typeface="Segoe UI"/>
+              </a:defRPr>
+            </a:pPr>
+            <a:r>
+              <a:t>projectsalaryprediction</a:t>
+            </a:r>
+          </a:p>
+        </p:txBody>
+      </p:sp>
+      <p:sp>
+        <p:nvSpPr>
+          <p:cNvPr id="102" name="TextBox 101"/>
+          <p:cNvSpPr txBox="1"/>
+          <p:nvPr/>
+        </p:nvSpPr>
+        <p:spPr>
+          <a:xfrm>
+            <a:off x="9784080" y="2880360"/>
+            <a:ext cx="1920240" cy="274320"/>
+          </a:xfrm>
+          <a:prstGeom prst="rect">
+            <a:avLst/>
+          </a:prstGeom>
+          <a:noFill/>
+        </p:spPr>
+        <p:txBody>
+          <a:bodyPr wrap="square" lIns="0" rIns="0" tIns="0" bIns="0">
+            <a:spAutoFit/>
+          </a:bodyPr>
+          <a:lstStyle/>
+          <a:p>
+            <a:pPr algn="ctr">
+              <a:defRPr sz="800" b="0">
+                <a:solidFill>
+                  <a:srgbClr val="8B95A8"/>
+                </a:solidFill>
+                <a:latin typeface="Segoe UI"/>
+              </a:defRPr>
+            </a:pPr>
+            <a:r>
+              <a:t>.streamlit.app</a:t>
+            </a:r>
+          </a:p>
+        </p:txBody>
+      </p:sp>
+      <p:sp>
+        <p:nvSpPr>
+          <p:cNvPr id="103" name="Rectangle 102"/>
           <p:cNvSpPr/>
           <p:nvPr/>
         </p:nvSpPr>
@@ -7613,7 +7833,7 @@
       </p:sp>
       <p:sp>
         <p:nvSpPr>
-          <p:cNvPr id="98" name="Rectangle 97"/>
+          <p:cNvPr id="104" name="Rectangle 103"/>
           <p:cNvSpPr/>
           <p:nvPr/>
         </p:nvSpPr>
@@ -7656,7 +7876,7 @@
       </p:sp>
       <p:sp>
         <p:nvSpPr>
-          <p:cNvPr id="99" name="Rectangle 98"/>
+          <p:cNvPr id="105" name="Rectangle 104"/>
           <p:cNvSpPr/>
           <p:nvPr/>
         </p:nvSpPr>
@@ -7699,7 +7919,7 @@
       </p:sp>
       <p:sp>
         <p:nvSpPr>
-          <p:cNvPr id="100" name="Rectangle 99"/>
+          <p:cNvPr id="106" name="Rectangle 105"/>
           <p:cNvSpPr/>
           <p:nvPr/>
         </p:nvSpPr>
@@ -7742,7 +7962,7 @@
       </p:sp>
       <p:sp>
         <p:nvSpPr>
-          <p:cNvPr id="101" name="Rectangle 100"/>
+          <p:cNvPr id="107" name="Rectangle 106"/>
           <p:cNvSpPr/>
           <p:nvPr/>
         </p:nvSpPr>
@@ -7785,7 +8005,7 @@
       </p:sp>
       <p:sp>
         <p:nvSpPr>
-          <p:cNvPr id="102" name="Rounded Rectangle 101"/>
+          <p:cNvPr id="108" name="Rounded Rectangle 107"/>
           <p:cNvSpPr/>
           <p:nvPr/>
         </p:nvSpPr>
@@ -7840,14 +8060,14 @@
       </p:sp>
       <p:sp>
         <p:nvSpPr>
-          <p:cNvPr id="103" name="TextBox 102"/>
+          <p:cNvPr id="109" name="TextBox 108"/>
           <p:cNvSpPr txBox="1"/>
           <p:nvPr/>
         </p:nvSpPr>
         <p:spPr>
           <a:xfrm>
             <a:off x="1097280" y="2606040"/>
-            <a:ext cx="10058400" cy="1280160"/>
+            <a:ext cx="8503920" cy="1280160"/>
           </a:xfrm>
           <a:prstGeom prst="rect">
             <a:avLst/>
@@ -7876,14 +8096,14 @@
       </p:sp>
       <p:sp>
         <p:nvSpPr>
-          <p:cNvPr id="104" name="TextBox 103"/>
+          <p:cNvPr id="110" name="TextBox 109"/>
           <p:cNvSpPr txBox="1"/>
           <p:nvPr/>
         </p:nvSpPr>
         <p:spPr>
           <a:xfrm>
             <a:off x="1097280" y="3794760"/>
-            <a:ext cx="10058400" cy="548640"/>
+            <a:ext cx="8503920" cy="548640"/>
           </a:xfrm>
           <a:prstGeom prst="rect">
             <a:avLst/>
@@ -7912,14 +8132,14 @@
       </p:sp>
       <p:sp>
         <p:nvSpPr>
-          <p:cNvPr id="105" name="TextBox 104"/>
+          <p:cNvPr id="111" name="TextBox 110"/>
           <p:cNvSpPr txBox="1"/>
           <p:nvPr/>
         </p:nvSpPr>
         <p:spPr>
           <a:xfrm>
             <a:off x="1097280" y="4343400"/>
-            <a:ext cx="10058400" cy="457200"/>
+            <a:ext cx="8503920" cy="457200"/>
           </a:xfrm>
           <a:prstGeom prst="rect">
             <a:avLst/>
@@ -7948,7 +8168,7 @@
       </p:sp>
       <p:sp>
         <p:nvSpPr>
-          <p:cNvPr id="106" name="TextBox 105"/>
+          <p:cNvPr id="112" name="TextBox 111"/>
           <p:cNvSpPr txBox="1"/>
           <p:nvPr/>
         </p:nvSpPr>
@@ -7984,7 +8204,7 @@
       </p:sp>
       <p:sp>
         <p:nvSpPr>
-          <p:cNvPr id="107" name="Rounded Rectangle 106"/>
+          <p:cNvPr id="113" name="Rounded Rectangle 112"/>
           <p:cNvSpPr/>
           <p:nvPr/>
         </p:nvSpPr>
@@ -8039,7 +8259,7 @@
       </p:sp>
       <p:sp>
         <p:nvSpPr>
-          <p:cNvPr id="108" name="Rounded Rectangle 107"/>
+          <p:cNvPr id="114" name="Rounded Rectangle 113"/>
           <p:cNvSpPr/>
           <p:nvPr/>
         </p:nvSpPr>
@@ -8094,7 +8314,7 @@
       </p:sp>
       <p:sp>
         <p:nvSpPr>
-          <p:cNvPr id="109" name="Rounded Rectangle 108"/>
+          <p:cNvPr id="115" name="Rounded Rectangle 114"/>
           <p:cNvSpPr/>
           <p:nvPr/>
         </p:nvSpPr>
@@ -8149,7 +8369,7 @@
       </p:sp>
       <p:sp>
         <p:nvSpPr>
-          <p:cNvPr id="110" name="Rounded Rectangle 109"/>
+          <p:cNvPr id="116" name="Rounded Rectangle 115"/>
           <p:cNvSpPr/>
           <p:nvPr/>
         </p:nvSpPr>
@@ -8226,16 +8446,16 @@
                       </p:stCondLst>
                       <p:childTnLst>
                         <p:par>
-                          <p:cTn id="4" presetID="10" presetClass="entr" presetSubtype="0" fill="hold" grpId="0" nodeType="withEffect">
+                          <p:cTn id="4" presetID="23" presetClass="entr" presetSubtype="0" fill="hold" grpId="0" nodeType="withEffect">
                             <p:stCondLst>
-                              <p:cond delay="0"/>
+                              <p:cond delay="1500"/>
                             </p:stCondLst>
                             <p:childTnLst>
                               <p:animEffect transition="in" filter="fade">
                                 <p:cBhvr>
                                   <p:cTn id="5" dur="500"/>
                                   <p:tgtEl>
-                                    <p:spTgt spid="102"/>
+                                    <p:spTgt spid="97"/>
                                   </p:tgtEl>
                                 </p:cBhvr>
                               </p:animEffect>
@@ -8254,14 +8474,14 @@
                         <p:par>
                           <p:cTn id="14" presetID="10" presetClass="entr" presetSubtype="0" fill="hold" grpId="0" nodeType="withEffect">
                             <p:stCondLst>
-                              <p:cond delay="300"/>
+                              <p:cond delay="0"/>
                             </p:stCondLst>
                             <p:childTnLst>
                               <p:animEffect transition="in" filter="fade">
                                 <p:cBhvr>
-                                  <p:cTn id="15" dur="700"/>
+                                  <p:cTn id="15" dur="500"/>
                                   <p:tgtEl>
-                                    <p:spTgt spid="103"/>
+                                    <p:spTgt spid="108"/>
                                   </p:tgtEl>
                                 </p:cBhvr>
                               </p:animEffect>
@@ -8280,14 +8500,14 @@
                         <p:par>
                           <p:cTn id="24" presetID="10" presetClass="entr" presetSubtype="0" fill="hold" grpId="0" nodeType="withEffect">
                             <p:stCondLst>
-                              <p:cond delay="600"/>
+                              <p:cond delay="300"/>
                             </p:stCondLst>
                             <p:childTnLst>
                               <p:animEffect transition="in" filter="fade">
                                 <p:cBhvr>
-                                  <p:cTn id="25" dur="500"/>
+                                  <p:cTn id="25" dur="700"/>
                                   <p:tgtEl>
-                                    <p:spTgt spid="104"/>
+                                    <p:spTgt spid="109"/>
                                   </p:tgtEl>
                                 </p:cBhvr>
                               </p:animEffect>
@@ -8306,14 +8526,14 @@
                         <p:par>
                           <p:cTn id="34" presetID="10" presetClass="entr" presetSubtype="0" fill="hold" grpId="0" nodeType="withEffect">
                             <p:stCondLst>
-                              <p:cond delay="900"/>
+                              <p:cond delay="600"/>
                             </p:stCondLst>
                             <p:childTnLst>
                               <p:animEffect transition="in" filter="fade">
                                 <p:cBhvr>
                                   <p:cTn id="35" dur="500"/>
                                   <p:tgtEl>
-                                    <p:spTgt spid="105"/>
+                                    <p:spTgt spid="110"/>
                                   </p:tgtEl>
                                 </p:cBhvr>
                               </p:animEffect>
@@ -8332,14 +8552,14 @@
                         <p:par>
                           <p:cTn id="44" presetID="10" presetClass="entr" presetSubtype="0" fill="hold" grpId="0" nodeType="withEffect">
                             <p:stCondLst>
-                              <p:cond delay="1200"/>
+                              <p:cond delay="900"/>
                             </p:stCondLst>
                             <p:childTnLst>
                               <p:animEffect transition="in" filter="fade">
                                 <p:cBhvr>
-                                  <p:cTn id="45" dur="400"/>
+                                  <p:cTn id="45" dur="500"/>
                                   <p:tgtEl>
-                                    <p:spTgt spid="106"/>
+                                    <p:spTgt spid="111"/>
                                   </p:tgtEl>
                                 </p:cBhvr>
                               </p:animEffect>
@@ -8356,16 +8576,16 @@
                       </p:stCondLst>
                       <p:childTnLst>
                         <p:par>
-                          <p:cTn id="54" presetID="23" presetClass="entr" presetSubtype="0" fill="hold" grpId="0" nodeType="withEffect">
+                          <p:cTn id="54" presetID="10" presetClass="entr" presetSubtype="0" fill="hold" grpId="0" nodeType="withEffect">
                             <p:stCondLst>
-                              <p:cond delay="1400"/>
+                              <p:cond delay="1200"/>
                             </p:stCondLst>
                             <p:childTnLst>
                               <p:animEffect transition="in" filter="fade">
                                 <p:cBhvr>
                                   <p:cTn id="55" dur="400"/>
                                   <p:tgtEl>
-                                    <p:spTgt spid="107"/>
+                                    <p:spTgt spid="112"/>
                                   </p:tgtEl>
                                 </p:cBhvr>
                               </p:animEffect>
@@ -8384,14 +8604,14 @@
                         <p:par>
                           <p:cTn id="64" presetID="23" presetClass="entr" presetSubtype="0" fill="hold" grpId="0" nodeType="withEffect">
                             <p:stCondLst>
-                              <p:cond delay="1550"/>
+                              <p:cond delay="1400"/>
                             </p:stCondLst>
                             <p:childTnLst>
                               <p:animEffect transition="in" filter="fade">
                                 <p:cBhvr>
                                   <p:cTn id="65" dur="400"/>
                                   <p:tgtEl>
-                                    <p:spTgt spid="108"/>
+                                    <p:spTgt spid="113"/>
                                   </p:tgtEl>
                                 </p:cBhvr>
                               </p:animEffect>
@@ -8410,14 +8630,14 @@
                         <p:par>
                           <p:cTn id="74" presetID="23" presetClass="entr" presetSubtype="0" fill="hold" grpId="0" nodeType="withEffect">
                             <p:stCondLst>
-                              <p:cond delay="1700"/>
+                              <p:cond delay="1550"/>
                             </p:stCondLst>
                             <p:childTnLst>
                               <p:animEffect transition="in" filter="fade">
                                 <p:cBhvr>
                                   <p:cTn id="75" dur="400"/>
                                   <p:tgtEl>
-                                    <p:spTgt spid="109"/>
+                                    <p:spTgt spid="114"/>
                                   </p:tgtEl>
                                 </p:cBhvr>
                               </p:animEffect>
@@ -8436,14 +8656,40 @@
                         <p:par>
                           <p:cTn id="84" presetID="23" presetClass="entr" presetSubtype="0" fill="hold" grpId="0" nodeType="withEffect">
                             <p:stCondLst>
-                              <p:cond delay="1850"/>
+                              <p:cond delay="1700"/>
                             </p:stCondLst>
                             <p:childTnLst>
                               <p:animEffect transition="in" filter="fade">
                                 <p:cBhvr>
                                   <p:cTn id="85" dur="400"/>
                                   <p:tgtEl>
-                                    <p:spTgt spid="110"/>
+                                    <p:spTgt spid="115"/>
+                                  </p:tgtEl>
+                                </p:cBhvr>
+                              </p:animEffect>
+                            </p:childTnLst>
+                          </p:cTn>
+                        </p:par>
+                      </p:childTnLst>
+                    </p:cTn>
+                  </p:par>
+                  <p:par>
+                    <p:cTn id="93" fill="hold">
+                      <p:stCondLst>
+                        <p:cond delay="0"/>
+                      </p:stCondLst>
+                      <p:childTnLst>
+                        <p:par>
+                          <p:cTn id="94" presetID="23" presetClass="entr" presetSubtype="0" fill="hold" grpId="0" nodeType="withEffect">
+                            <p:stCondLst>
+                              <p:cond delay="1850"/>
+                            </p:stCondLst>
+                            <p:childTnLst>
+                              <p:animEffect transition="in" filter="fade">
+                                <p:cBhvr>
+                                  <p:cTn id="95" dur="400"/>
+                                  <p:tgtEl>
+                                    <p:spTgt spid="116"/>
                                   </p:tgtEl>
                                 </p:cBhvr>
                               </p:animEffect>

</xml_diff>